<commit_message>
adding portuguese changing intro, adding dropdown to sections
</commit_message>
<xml_diff>
--- a/images/section3/flags.pptx
+++ b/images/section3/flags.pptx
@@ -9,6 +9,8 @@
     <p:sldId id="257" r:id="rId3"/>
     <p:sldId id="258" r:id="rId4"/>
     <p:sldId id="259" r:id="rId5"/>
+    <p:sldId id="261" r:id="rId6"/>
+    <p:sldId id="260" r:id="rId7"/>
   </p:sldIdLst>
   <p:sldSz cx="12192000" cy="6858000"/>
   <p:notesSz cx="6858000" cy="9144000"/>
@@ -115,6 +117,14 @@
 </p:presentation>
 </file>
 
+<file path=ppt/revisionInfo.xml><?xml version="1.0" encoding="utf-8"?>
+<p1510:revInfo xmlns:a="http://schemas.openxmlformats.org/drawingml/2006/main" xmlns:r="http://schemas.openxmlformats.org/officeDocument/2006/relationships" xmlns:p1510="http://schemas.microsoft.com/office/powerpoint/2015/10/main">
+  <p1510:revLst>
+    <p1510:client id="{3534CE55-EAA9-498E-8ABD-B7EB8A0E4B77}" v="17" dt="2025-09-26T12:39:10.879"/>
+  </p1510:revLst>
+</p1510:revInfo>
+</file>
+
 <file path=ppt/changesInfos/changesInfo1.xml><?xml version="1.0" encoding="utf-8"?>
 <pc:chgInfo xmlns:a="http://schemas.openxmlformats.org/drawingml/2006/main" xmlns:r="http://schemas.openxmlformats.org/officeDocument/2006/relationships" xmlns:ac="http://schemas.microsoft.com/office/drawing/2013/main/command" xmlns:pc="http://schemas.microsoft.com/office/powerpoint/2013/main/command">
   <pc:docChgLst>
@@ -130,38 +140,6 @@
           <pc:docMk/>
           <pc:sldMk cId="3160763502" sldId="256"/>
         </pc:sldMkLst>
-        <pc:spChg chg="del">
-          <ac:chgData name="Lorenzo Taddei" userId="30bf616d265f9878" providerId="LiveId" clId="{3CFE4D1B-D6E8-4B8C-8AF7-BE806EC0D969}" dt="2023-02-13T10:00:32.657" v="1" actId="478"/>
-          <ac:spMkLst>
-            <pc:docMk/>
-            <pc:sldMk cId="3160763502" sldId="256"/>
-            <ac:spMk id="2" creationId="{D658B7E0-8688-975F-9A6C-3855EE65BD69}"/>
-          </ac:spMkLst>
-        </pc:spChg>
-        <pc:spChg chg="del">
-          <ac:chgData name="Lorenzo Taddei" userId="30bf616d265f9878" providerId="LiveId" clId="{3CFE4D1B-D6E8-4B8C-8AF7-BE806EC0D969}" dt="2023-02-13T10:00:32.657" v="1" actId="478"/>
-          <ac:spMkLst>
-            <pc:docMk/>
-            <pc:sldMk cId="3160763502" sldId="256"/>
-            <ac:spMk id="3" creationId="{AC47246C-7F51-0763-FB7D-92B50F2988E5}"/>
-          </ac:spMkLst>
-        </pc:spChg>
-        <pc:spChg chg="add mod ord">
-          <ac:chgData name="Lorenzo Taddei" userId="30bf616d265f9878" providerId="LiveId" clId="{3CFE4D1B-D6E8-4B8C-8AF7-BE806EC0D969}" dt="2023-02-13T10:04:26.283" v="27" actId="171"/>
-          <ac:spMkLst>
-            <pc:docMk/>
-            <pc:sldMk cId="3160763502" sldId="256"/>
-            <ac:spMk id="6" creationId="{D1EC6880-5550-2593-68D4-E95F0C3E1259}"/>
-          </ac:spMkLst>
-        </pc:spChg>
-        <pc:picChg chg="add mod">
-          <ac:chgData name="Lorenzo Taddei" userId="30bf616d265f9878" providerId="LiveId" clId="{3CFE4D1B-D6E8-4B8C-8AF7-BE806EC0D969}" dt="2023-02-13T10:04:33.892" v="28" actId="1076"/>
-          <ac:picMkLst>
-            <pc:docMk/>
-            <pc:sldMk cId="3160763502" sldId="256"/>
-            <ac:picMk id="5" creationId="{E0648D03-358F-CA18-8857-76CA9BC0775B}"/>
-          </ac:picMkLst>
-        </pc:picChg>
       </pc:sldChg>
       <pc:sldChg chg="addSp delSp modSp add mod">
         <pc:chgData name="Lorenzo Taddei" userId="30bf616d265f9878" providerId="LiveId" clId="{3CFE4D1B-D6E8-4B8C-8AF7-BE806EC0D969}" dt="2023-02-13T10:08:17.343" v="58" actId="2085"/>
@@ -169,30 +147,6 @@
           <pc:docMk/>
           <pc:sldMk cId="908061509" sldId="257"/>
         </pc:sldMkLst>
-        <pc:spChg chg="add mod">
-          <ac:chgData name="Lorenzo Taddei" userId="30bf616d265f9878" providerId="LiveId" clId="{3CFE4D1B-D6E8-4B8C-8AF7-BE806EC0D969}" dt="2023-02-13T10:08:17.343" v="58" actId="2085"/>
-          <ac:spMkLst>
-            <pc:docMk/>
-            <pc:sldMk cId="908061509" sldId="257"/>
-            <ac:spMk id="3" creationId="{BD7AF15C-8DEB-FC08-752E-4968750864A9}"/>
-          </ac:spMkLst>
-        </pc:spChg>
-        <pc:picChg chg="add mod ord">
-          <ac:chgData name="Lorenzo Taddei" userId="30bf616d265f9878" providerId="LiveId" clId="{3CFE4D1B-D6E8-4B8C-8AF7-BE806EC0D969}" dt="2023-02-13T10:05:12.855" v="41" actId="14100"/>
-          <ac:picMkLst>
-            <pc:docMk/>
-            <pc:sldMk cId="908061509" sldId="257"/>
-            <ac:picMk id="2" creationId="{0D41835F-FF49-9303-D406-262BC1BE402B}"/>
-          </ac:picMkLst>
-        </pc:picChg>
-        <pc:picChg chg="del">
-          <ac:chgData name="Lorenzo Taddei" userId="30bf616d265f9878" providerId="LiveId" clId="{3CFE4D1B-D6E8-4B8C-8AF7-BE806EC0D969}" dt="2023-02-13T10:01:59.153" v="5" actId="478"/>
-          <ac:picMkLst>
-            <pc:docMk/>
-            <pc:sldMk cId="908061509" sldId="257"/>
-            <ac:picMk id="5" creationId="{E0648D03-358F-CA18-8857-76CA9BC0775B}"/>
-          </ac:picMkLst>
-        </pc:picChg>
       </pc:sldChg>
       <pc:sldChg chg="addSp delSp modSp add mod">
         <pc:chgData name="Lorenzo Taddei" userId="30bf616d265f9878" providerId="LiveId" clId="{3CFE4D1B-D6E8-4B8C-8AF7-BE806EC0D969}" dt="2023-02-13T10:05:45.032" v="45" actId="1076"/>
@@ -200,38 +154,6 @@
           <pc:docMk/>
           <pc:sldMk cId="2006234374" sldId="258"/>
         </pc:sldMkLst>
-        <pc:spChg chg="add mod ord">
-          <ac:chgData name="Lorenzo Taddei" userId="30bf616d265f9878" providerId="LiveId" clId="{3CFE4D1B-D6E8-4B8C-8AF7-BE806EC0D969}" dt="2023-02-13T10:05:23.315" v="42" actId="167"/>
-          <ac:spMkLst>
-            <pc:docMk/>
-            <pc:sldMk cId="2006234374" sldId="258"/>
-            <ac:spMk id="7" creationId="{B2DFA5D0-02B8-C032-3CBA-150AE639EBDD}"/>
-          </ac:spMkLst>
-        </pc:spChg>
-        <pc:picChg chg="add mod">
-          <ac:chgData name="Lorenzo Taddei" userId="30bf616d265f9878" providerId="LiveId" clId="{3CFE4D1B-D6E8-4B8C-8AF7-BE806EC0D969}" dt="2023-02-13T10:05:45.032" v="45" actId="1076"/>
-          <ac:picMkLst>
-            <pc:docMk/>
-            <pc:sldMk cId="2006234374" sldId="258"/>
-            <ac:picMk id="3" creationId="{2EBCFDB8-5A12-C2DA-71D7-78B9251BB786}"/>
-          </ac:picMkLst>
-        </pc:picChg>
-        <pc:picChg chg="del">
-          <ac:chgData name="Lorenzo Taddei" userId="30bf616d265f9878" providerId="LiveId" clId="{3CFE4D1B-D6E8-4B8C-8AF7-BE806EC0D969}" dt="2023-02-13T10:02:04.371" v="6" actId="478"/>
-          <ac:picMkLst>
-            <pc:docMk/>
-            <pc:sldMk cId="2006234374" sldId="258"/>
-            <ac:picMk id="5" creationId="{E0648D03-358F-CA18-8857-76CA9BC0775B}"/>
-          </ac:picMkLst>
-        </pc:picChg>
-        <pc:picChg chg="add del mod">
-          <ac:chgData name="Lorenzo Taddei" userId="30bf616d265f9878" providerId="LiveId" clId="{3CFE4D1B-D6E8-4B8C-8AF7-BE806EC0D969}" dt="2023-02-13T10:02:13.332" v="9" actId="478"/>
-          <ac:picMkLst>
-            <pc:docMk/>
-            <pc:sldMk cId="2006234374" sldId="258"/>
-            <ac:picMk id="6" creationId="{FF8F8051-433D-D295-03DB-36D10B85CFBD}"/>
-          </ac:picMkLst>
-        </pc:picChg>
       </pc:sldChg>
       <pc:sldChg chg="addSp delSp modSp add mod">
         <pc:chgData name="Lorenzo Taddei" userId="30bf616d265f9878" providerId="LiveId" clId="{3CFE4D1B-D6E8-4B8C-8AF7-BE806EC0D969}" dt="2023-02-13T10:08:07.923" v="57" actId="1076"/>
@@ -239,22 +161,6 @@
           <pc:docMk/>
           <pc:sldMk cId="1068699948" sldId="259"/>
         </pc:sldMkLst>
-        <pc:picChg chg="del">
-          <ac:chgData name="Lorenzo Taddei" userId="30bf616d265f9878" providerId="LiveId" clId="{3CFE4D1B-D6E8-4B8C-8AF7-BE806EC0D969}" dt="2023-02-13T10:05:47.709" v="46" actId="478"/>
-          <ac:picMkLst>
-            <pc:docMk/>
-            <pc:sldMk cId="1068699948" sldId="259"/>
-            <ac:picMk id="3" creationId="{2EBCFDB8-5A12-C2DA-71D7-78B9251BB786}"/>
-          </ac:picMkLst>
-        </pc:picChg>
-        <pc:picChg chg="add mod">
-          <ac:chgData name="Lorenzo Taddei" userId="30bf616d265f9878" providerId="LiveId" clId="{3CFE4D1B-D6E8-4B8C-8AF7-BE806EC0D969}" dt="2023-02-13T10:08:07.923" v="57" actId="1076"/>
-          <ac:picMkLst>
-            <pc:docMk/>
-            <pc:sldMk cId="1068699948" sldId="259"/>
-            <ac:picMk id="4" creationId="{20B9406F-15DF-D2C4-CC8D-AB0E26347F13}"/>
-          </ac:picMkLst>
-        </pc:picChg>
       </pc:sldChg>
     </pc:docChg>
   </pc:docChgLst>
@@ -271,14 +177,6 @@
           <pc:docMk/>
           <pc:sldMk cId="2006234374" sldId="258"/>
         </pc:sldMkLst>
-        <pc:picChg chg="mod">
-          <ac:chgData name="Lorenzo Taddei" userId="30bf616d265f9878" providerId="LiveId" clId="{0AB97BD2-0743-4355-A7B9-A8D483BDB783}" dt="2023-02-14T10:32:54.879" v="0" actId="29295"/>
-          <ac:picMkLst>
-            <pc:docMk/>
-            <pc:sldMk cId="2006234374" sldId="258"/>
-            <ac:picMk id="3" creationId="{2EBCFDB8-5A12-C2DA-71D7-78B9251BB786}"/>
-          </ac:picMkLst>
-        </pc:picChg>
       </pc:sldChg>
       <pc:sldChg chg="modSp mod">
         <pc:chgData name="Lorenzo Taddei" userId="30bf616d265f9878" providerId="LiveId" clId="{0AB97BD2-0743-4355-A7B9-A8D483BDB783}" dt="2023-02-14T10:33:03.489" v="1" actId="29295"/>
@@ -286,12 +184,146 @@
           <pc:docMk/>
           <pc:sldMk cId="1068699948" sldId="259"/>
         </pc:sldMkLst>
-        <pc:picChg chg="mod">
-          <ac:chgData name="Lorenzo Taddei" userId="30bf616d265f9878" providerId="LiveId" clId="{0AB97BD2-0743-4355-A7B9-A8D483BDB783}" dt="2023-02-14T10:33:03.489" v="1" actId="29295"/>
+      </pc:sldChg>
+    </pc:docChg>
+  </pc:docChgLst>
+  <pc:docChgLst>
+    <pc:chgData name="Lorenzo Taddei" userId="30bf616d265f9878" providerId="LiveId" clId="{6FD03176-F394-4DE9-9E07-BC8A4F6F06C0}"/>
+    <pc:docChg chg="undo redo custSel addSld delSld modSld">
+      <pc:chgData name="Lorenzo Taddei" userId="30bf616d265f9878" providerId="LiveId" clId="{6FD03176-F394-4DE9-9E07-BC8A4F6F06C0}" dt="2025-09-26T12:39:22.247" v="149" actId="207"/>
+      <pc:docMkLst>
+        <pc:docMk/>
+      </pc:docMkLst>
+      <pc:sldChg chg="addSp delSp modSp add mod">
+        <pc:chgData name="Lorenzo Taddei" userId="30bf616d265f9878" providerId="LiveId" clId="{6FD03176-F394-4DE9-9E07-BC8A4F6F06C0}" dt="2025-09-26T12:36:43.871" v="63" actId="164"/>
+        <pc:sldMkLst>
+          <pc:docMk/>
+          <pc:sldMk cId="4165855930" sldId="260"/>
+        </pc:sldMkLst>
+        <pc:spChg chg="add del mod">
+          <ac:chgData name="Lorenzo Taddei" userId="30bf616d265f9878" providerId="LiveId" clId="{6FD03176-F394-4DE9-9E07-BC8A4F6F06C0}" dt="2025-09-26T12:34:44.288" v="17"/>
+          <ac:spMkLst>
+            <pc:docMk/>
+            <pc:sldMk cId="4165855930" sldId="260"/>
+            <ac:spMk id="3" creationId="{6FBAE034-C113-3AC1-59B9-7F7C62E06A0E}"/>
+          </ac:spMkLst>
+        </pc:spChg>
+        <pc:spChg chg="ord">
+          <ac:chgData name="Lorenzo Taddei" userId="30bf616d265f9878" providerId="LiveId" clId="{6FD03176-F394-4DE9-9E07-BC8A4F6F06C0}" dt="2025-09-26T12:35:26.710" v="25" actId="167"/>
+          <ac:spMkLst>
+            <pc:docMk/>
+            <pc:sldMk cId="4165855930" sldId="260"/>
+            <ac:spMk id="7" creationId="{7D1E5580-B561-57BB-5479-9E3EB91E1C90}"/>
+          </ac:spMkLst>
+        </pc:spChg>
+        <pc:grpChg chg="add mod">
+          <ac:chgData name="Lorenzo Taddei" userId="30bf616d265f9878" providerId="LiveId" clId="{6FD03176-F394-4DE9-9E07-BC8A4F6F06C0}" dt="2025-09-26T12:36:43.871" v="63" actId="164"/>
+          <ac:grpSpMkLst>
+            <pc:docMk/>
+            <pc:sldMk cId="4165855930" sldId="260"/>
+            <ac:grpSpMk id="8" creationId="{3188279F-69C1-73D9-3D9A-B4F4503179B1}"/>
+          </ac:grpSpMkLst>
+        </pc:grpChg>
+        <pc:picChg chg="add mod">
+          <ac:chgData name="Lorenzo Taddei" userId="30bf616d265f9878" providerId="LiveId" clId="{6FD03176-F394-4DE9-9E07-BC8A4F6F06C0}" dt="2025-09-26T12:32:41.789" v="5" actId="1076"/>
           <ac:picMkLst>
             <pc:docMk/>
-            <pc:sldMk cId="1068699948" sldId="259"/>
-            <ac:picMk id="4" creationId="{20B9406F-15DF-D2C4-CC8D-AB0E26347F13}"/>
+            <pc:sldMk cId="4165855930" sldId="260"/>
+            <ac:picMk id="2" creationId="{990572E3-7EBB-764B-29A6-391900F9B3CB}"/>
+          </ac:picMkLst>
+        </pc:picChg>
+        <pc:picChg chg="del mod">
+          <ac:chgData name="Lorenzo Taddei" userId="30bf616d265f9878" providerId="LiveId" clId="{6FD03176-F394-4DE9-9E07-BC8A4F6F06C0}" dt="2025-09-26T12:34:44.288" v="17"/>
+          <ac:picMkLst>
+            <pc:docMk/>
+            <pc:sldMk cId="4165855930" sldId="260"/>
+            <ac:picMk id="4" creationId="{8B4C5083-87C2-9DF9-0C4F-4FFF8F8E811C}"/>
+          </ac:picMkLst>
+        </pc:picChg>
+        <pc:picChg chg="mod">
+          <ac:chgData name="Lorenzo Taddei" userId="30bf616d265f9878" providerId="LiveId" clId="{6FD03176-F394-4DE9-9E07-BC8A4F6F06C0}" dt="2025-09-26T12:36:43.871" v="63" actId="164"/>
+          <ac:picMkLst>
+            <pc:docMk/>
+            <pc:sldMk cId="4165855930" sldId="260"/>
+            <ac:picMk id="5" creationId="{01330D20-84CA-EB01-C1B5-0C16711542AF}"/>
+          </ac:picMkLst>
+        </pc:picChg>
+        <pc:picChg chg="add mod ord">
+          <ac:chgData name="Lorenzo Taddei" userId="30bf616d265f9878" providerId="LiveId" clId="{6FD03176-F394-4DE9-9E07-BC8A4F6F06C0}" dt="2025-09-26T12:36:43.871" v="63" actId="164"/>
+          <ac:picMkLst>
+            <pc:docMk/>
+            <pc:sldMk cId="4165855930" sldId="260"/>
+            <ac:picMk id="6" creationId="{B4E5DC63-4C58-F4C0-FC26-02797FF23A8D}"/>
+          </ac:picMkLst>
+        </pc:picChg>
+      </pc:sldChg>
+      <pc:sldChg chg="add del">
+        <pc:chgData name="Lorenzo Taddei" userId="30bf616d265f9878" providerId="LiveId" clId="{6FD03176-F394-4DE9-9E07-BC8A4F6F06C0}" dt="2025-09-26T12:32:31.058" v="3"/>
+        <pc:sldMkLst>
+          <pc:docMk/>
+          <pc:sldMk cId="2437045536" sldId="261"/>
+        </pc:sldMkLst>
+      </pc:sldChg>
+      <pc:sldChg chg="addSp delSp modSp add mod">
+        <pc:chgData name="Lorenzo Taddei" userId="30bf616d265f9878" providerId="LiveId" clId="{6FD03176-F394-4DE9-9E07-BC8A4F6F06C0}" dt="2025-09-26T12:39:22.247" v="149" actId="207"/>
+        <pc:sldMkLst>
+          <pc:docMk/>
+          <pc:sldMk cId="4011292387" sldId="261"/>
+        </pc:sldMkLst>
+        <pc:spChg chg="add del mod">
+          <ac:chgData name="Lorenzo Taddei" userId="30bf616d265f9878" providerId="LiveId" clId="{6FD03176-F394-4DE9-9E07-BC8A4F6F06C0}" dt="2025-09-26T12:39:08.227" v="107" actId="478"/>
+          <ac:spMkLst>
+            <pc:docMk/>
+            <pc:sldMk cId="4011292387" sldId="261"/>
+            <ac:spMk id="6" creationId="{FA7322B7-C96F-4192-B539-3B273ABE2A86}"/>
+          </ac:spMkLst>
+        </pc:spChg>
+        <pc:spChg chg="ord">
+          <ac:chgData name="Lorenzo Taddei" userId="30bf616d265f9878" providerId="LiveId" clId="{6FD03176-F394-4DE9-9E07-BC8A4F6F06C0}" dt="2025-09-26T12:37:44.377" v="74" actId="167"/>
+          <ac:spMkLst>
+            <pc:docMk/>
+            <pc:sldMk cId="4011292387" sldId="261"/>
+            <ac:spMk id="7" creationId="{9F1CB320-5B49-94CE-2FBB-A29DF8C1775B}"/>
+          </ac:spMkLst>
+        </pc:spChg>
+        <pc:spChg chg="add mod">
+          <ac:chgData name="Lorenzo Taddei" userId="30bf616d265f9878" providerId="LiveId" clId="{6FD03176-F394-4DE9-9E07-BC8A4F6F06C0}" dt="2025-09-26T12:39:22.247" v="149" actId="207"/>
+          <ac:spMkLst>
+            <pc:docMk/>
+            <pc:sldMk cId="4011292387" sldId="261"/>
+            <ac:spMk id="8" creationId="{CFEE4C96-829E-27AB-D817-7178F2E0ACDB}"/>
+          </ac:spMkLst>
+        </pc:spChg>
+        <pc:grpChg chg="add mod ord">
+          <ac:chgData name="Lorenzo Taddei" userId="30bf616d265f9878" providerId="LiveId" clId="{6FD03176-F394-4DE9-9E07-BC8A4F6F06C0}" dt="2025-09-26T12:37:58.093" v="81" actId="14861"/>
+          <ac:grpSpMkLst>
+            <pc:docMk/>
+            <pc:sldMk cId="4011292387" sldId="261"/>
+            <ac:grpSpMk id="2" creationId="{3FC94205-F7D5-8ACF-A915-1BFB7428EB61}"/>
+          </ac:grpSpMkLst>
+        </pc:grpChg>
+        <pc:picChg chg="mod">
+          <ac:chgData name="Lorenzo Taddei" userId="30bf616d265f9878" providerId="LiveId" clId="{6FD03176-F394-4DE9-9E07-BC8A4F6F06C0}" dt="2025-09-26T12:38:17.271" v="103" actId="29295"/>
+          <ac:picMkLst>
+            <pc:docMk/>
+            <pc:sldMk cId="4011292387" sldId="261"/>
+            <ac:picMk id="3" creationId="{1626B058-DDF0-E23C-70BB-9DB237C1E518}"/>
+          </ac:picMkLst>
+        </pc:picChg>
+        <pc:picChg chg="add del">
+          <ac:chgData name="Lorenzo Taddei" userId="30bf616d265f9878" providerId="LiveId" clId="{6FD03176-F394-4DE9-9E07-BC8A4F6F06C0}" dt="2025-09-26T12:37:43.977" v="73" actId="478"/>
+          <ac:picMkLst>
+            <pc:docMk/>
+            <pc:sldMk cId="4011292387" sldId="261"/>
+            <ac:picMk id="4" creationId="{AFFB909D-8069-B903-E703-68F137603670}"/>
+          </ac:picMkLst>
+        </pc:picChg>
+        <pc:picChg chg="mod">
+          <ac:chgData name="Lorenzo Taddei" userId="30bf616d265f9878" providerId="LiveId" clId="{6FD03176-F394-4DE9-9E07-BC8A4F6F06C0}" dt="2025-09-26T12:38:17.271" v="103" actId="29295"/>
+          <ac:picMkLst>
+            <pc:docMk/>
+            <pc:sldMk cId="4011292387" sldId="261"/>
+            <ac:picMk id="5" creationId="{C42F9831-FC97-5C85-8577-6590048978F4}"/>
           </ac:picMkLst>
         </pc:picChg>
       </pc:sldChg>
@@ -449,7 +481,7 @@
           <a:p>
             <a:fld id="{9A4AF60B-EE12-4DA8-A3AC-DF689C975724}" type="datetimeFigureOut">
               <a:rPr lang="it-IT" smtClean="0"/>
-              <a:t>14/02/2023</a:t>
+              <a:t>26/09/2025</a:t>
             </a:fld>
             <a:endParaRPr lang="it-IT"/>
           </a:p>
@@ -649,7 +681,7 @@
           <a:p>
             <a:fld id="{9A4AF60B-EE12-4DA8-A3AC-DF689C975724}" type="datetimeFigureOut">
               <a:rPr lang="it-IT" smtClean="0"/>
-              <a:t>14/02/2023</a:t>
+              <a:t>26/09/2025</a:t>
             </a:fld>
             <a:endParaRPr lang="it-IT"/>
           </a:p>
@@ -859,7 +891,7 @@
           <a:p>
             <a:fld id="{9A4AF60B-EE12-4DA8-A3AC-DF689C975724}" type="datetimeFigureOut">
               <a:rPr lang="it-IT" smtClean="0"/>
-              <a:t>14/02/2023</a:t>
+              <a:t>26/09/2025</a:t>
             </a:fld>
             <a:endParaRPr lang="it-IT"/>
           </a:p>
@@ -1059,7 +1091,7 @@
           <a:p>
             <a:fld id="{9A4AF60B-EE12-4DA8-A3AC-DF689C975724}" type="datetimeFigureOut">
               <a:rPr lang="it-IT" smtClean="0"/>
-              <a:t>14/02/2023</a:t>
+              <a:t>26/09/2025</a:t>
             </a:fld>
             <a:endParaRPr lang="it-IT"/>
           </a:p>
@@ -1335,7 +1367,7 @@
           <a:p>
             <a:fld id="{9A4AF60B-EE12-4DA8-A3AC-DF689C975724}" type="datetimeFigureOut">
               <a:rPr lang="it-IT" smtClean="0"/>
-              <a:t>14/02/2023</a:t>
+              <a:t>26/09/2025</a:t>
             </a:fld>
             <a:endParaRPr lang="it-IT"/>
           </a:p>
@@ -1603,7 +1635,7 @@
           <a:p>
             <a:fld id="{9A4AF60B-EE12-4DA8-A3AC-DF689C975724}" type="datetimeFigureOut">
               <a:rPr lang="it-IT" smtClean="0"/>
-              <a:t>14/02/2023</a:t>
+              <a:t>26/09/2025</a:t>
             </a:fld>
             <a:endParaRPr lang="it-IT"/>
           </a:p>
@@ -2018,7 +2050,7 @@
           <a:p>
             <a:fld id="{9A4AF60B-EE12-4DA8-A3AC-DF689C975724}" type="datetimeFigureOut">
               <a:rPr lang="it-IT" smtClean="0"/>
-              <a:t>14/02/2023</a:t>
+              <a:t>26/09/2025</a:t>
             </a:fld>
             <a:endParaRPr lang="it-IT"/>
           </a:p>
@@ -2160,7 +2192,7 @@
           <a:p>
             <a:fld id="{9A4AF60B-EE12-4DA8-A3AC-DF689C975724}" type="datetimeFigureOut">
               <a:rPr lang="it-IT" smtClean="0"/>
-              <a:t>14/02/2023</a:t>
+              <a:t>26/09/2025</a:t>
             </a:fld>
             <a:endParaRPr lang="it-IT"/>
           </a:p>
@@ -2273,7 +2305,7 @@
           <a:p>
             <a:fld id="{9A4AF60B-EE12-4DA8-A3AC-DF689C975724}" type="datetimeFigureOut">
               <a:rPr lang="it-IT" smtClean="0"/>
-              <a:t>14/02/2023</a:t>
+              <a:t>26/09/2025</a:t>
             </a:fld>
             <a:endParaRPr lang="it-IT"/>
           </a:p>
@@ -2586,7 +2618,7 @@
           <a:p>
             <a:fld id="{9A4AF60B-EE12-4DA8-A3AC-DF689C975724}" type="datetimeFigureOut">
               <a:rPr lang="it-IT" smtClean="0"/>
-              <a:t>14/02/2023</a:t>
+              <a:t>26/09/2025</a:t>
             </a:fld>
             <a:endParaRPr lang="it-IT"/>
           </a:p>
@@ -2875,7 +2907,7 @@
           <a:p>
             <a:fld id="{9A4AF60B-EE12-4DA8-A3AC-DF689C975724}" type="datetimeFigureOut">
               <a:rPr lang="it-IT" smtClean="0"/>
-              <a:t>14/02/2023</a:t>
+              <a:t>26/09/2025</a:t>
             </a:fld>
             <a:endParaRPr lang="it-IT"/>
           </a:p>
@@ -3118,7 +3150,7 @@
           <a:p>
             <a:fld id="{9A4AF60B-EE12-4DA8-A3AC-DF689C975724}" type="datetimeFigureOut">
               <a:rPr lang="it-IT" smtClean="0"/>
-              <a:t>14/02/2023</a:t>
+              <a:t>26/09/2025</a:t>
             </a:fld>
             <a:endParaRPr lang="it-IT"/>
           </a:p>
@@ -3998,6 +4030,699 @@
 </p:sld>
 </file>
 
+<file path=ppt/slides/slide5.xml><?xml version="1.0" encoding="utf-8"?>
+<p:sld xmlns:a="http://schemas.openxmlformats.org/drawingml/2006/main" xmlns:r="http://schemas.openxmlformats.org/officeDocument/2006/relationships" xmlns:p="http://schemas.openxmlformats.org/presentationml/2006/main">
+  <p:cSld>
+    <p:spTree>
+      <p:nvGrpSpPr>
+        <p:cNvPr id="1" name="">
+          <a:extLst>
+            <a:ext uri="{FF2B5EF4-FFF2-40B4-BE49-F238E27FC236}">
+              <a16:creationId xmlns:a16="http://schemas.microsoft.com/office/drawing/2014/main" id="{96802124-7D57-ECB7-76D4-A00DE5A66789}"/>
+            </a:ext>
+          </a:extLst>
+        </p:cNvPr>
+        <p:cNvGrpSpPr/>
+        <p:nvPr/>
+      </p:nvGrpSpPr>
+      <p:grpSpPr>
+        <a:xfrm>
+          <a:off x="0" y="0"/>
+          <a:ext cx="0" cy="0"/>
+          <a:chOff x="0" y="0"/>
+          <a:chExt cx="0" cy="0"/>
+        </a:xfrm>
+      </p:grpSpPr>
+      <p:sp>
+        <p:nvSpPr>
+          <p:cNvPr id="7" name="Rectangle 6">
+            <a:extLst>
+              <a:ext uri="{FF2B5EF4-FFF2-40B4-BE49-F238E27FC236}">
+                <a16:creationId xmlns:a16="http://schemas.microsoft.com/office/drawing/2014/main" id="{9F1CB320-5B49-94CE-2FBB-A29DF8C1775B}"/>
+              </a:ext>
+            </a:extLst>
+          </p:cNvPr>
+          <p:cNvSpPr/>
+          <p:nvPr/>
+        </p:nvSpPr>
+        <p:spPr>
+          <a:xfrm>
+            <a:off x="0" y="0"/>
+            <a:ext cx="6583680" cy="3891280"/>
+          </a:xfrm>
+          <a:prstGeom prst="rect">
+            <a:avLst/>
+          </a:prstGeom>
+          <a:solidFill>
+            <a:schemeClr val="bg1"/>
+          </a:solidFill>
+          <a:ln>
+            <a:solidFill>
+              <a:schemeClr val="bg1"/>
+            </a:solidFill>
+          </a:ln>
+        </p:spPr>
+        <p:style>
+          <a:lnRef idx="2">
+            <a:schemeClr val="accent1">
+              <a:shade val="50000"/>
+            </a:schemeClr>
+          </a:lnRef>
+          <a:fillRef idx="1">
+            <a:schemeClr val="accent1"/>
+          </a:fillRef>
+          <a:effectRef idx="0">
+            <a:schemeClr val="accent1"/>
+          </a:effectRef>
+          <a:fontRef idx="minor">
+            <a:schemeClr val="lt1"/>
+          </a:fontRef>
+        </p:style>
+        <p:txBody>
+          <a:bodyPr rtlCol="0" anchor="ctr"/>
+          <a:lstStyle/>
+          <a:p>
+            <a:pPr algn="ctr"/>
+            <a:endParaRPr lang="it-IT"/>
+          </a:p>
+        </p:txBody>
+      </p:sp>
+      <p:grpSp>
+        <p:nvGrpSpPr>
+          <p:cNvPr id="2" name="Group 1">
+            <a:extLst>
+              <a:ext uri="{FF2B5EF4-FFF2-40B4-BE49-F238E27FC236}">
+                <a16:creationId xmlns:a16="http://schemas.microsoft.com/office/drawing/2014/main" id="{3FC94205-F7D5-8ACF-A915-1BFB7428EB61}"/>
+              </a:ext>
+            </a:extLst>
+          </p:cNvPr>
+          <p:cNvGrpSpPr/>
+          <p:nvPr/>
+        </p:nvGrpSpPr>
+        <p:grpSpPr>
+          <a:xfrm>
+            <a:off x="1346200" y="0"/>
+            <a:ext cx="3891280" cy="3891280"/>
+            <a:chOff x="497332" y="1076960"/>
+            <a:chExt cx="4618736" cy="4618736"/>
+          </a:xfrm>
+        </p:grpSpPr>
+        <p:pic>
+          <p:nvPicPr>
+            <p:cNvPr id="3" name="Picture 2">
+              <a:extLst>
+                <a:ext uri="{FF2B5EF4-FFF2-40B4-BE49-F238E27FC236}">
+                  <a16:creationId xmlns:a16="http://schemas.microsoft.com/office/drawing/2014/main" id="{1626B058-DDF0-E23C-70BB-9DB237C1E518}"/>
+                </a:ext>
+              </a:extLst>
+            </p:cNvPr>
+            <p:cNvPicPr>
+              <a:picLocks noChangeAspect="1"/>
+            </p:cNvPicPr>
+            <p:nvPr/>
+          </p:nvPicPr>
+          <p:blipFill>
+            <a:blip r:embed="rId2">
+              <a:alphaModFix/>
+              <a:extLst>
+                <a:ext uri="{28A0092B-C50C-407E-A947-70E740481C1C}">
+                  <a14:useLocalDpi xmlns:a14="http://schemas.microsoft.com/office/drawing/2010/main" val="0"/>
+                </a:ext>
+              </a:extLst>
+            </a:blip>
+            <a:srcRect l="14850" r="22650"/>
+            <a:stretch/>
+          </p:blipFill>
+          <p:spPr>
+            <a:xfrm>
+              <a:off x="497332" y="1076960"/>
+              <a:ext cx="4618736" cy="4618736"/>
+            </a:xfrm>
+            <a:custGeom>
+              <a:avLst/>
+              <a:gdLst>
+                <a:gd name="connsiteX0" fmla="*/ 1945640 w 3891280"/>
+                <a:gd name="connsiteY0" fmla="*/ 0 h 3891280"/>
+                <a:gd name="connsiteX1" fmla="*/ 3891280 w 3891280"/>
+                <a:gd name="connsiteY1" fmla="*/ 1945640 h 3891280"/>
+                <a:gd name="connsiteX2" fmla="*/ 1945640 w 3891280"/>
+                <a:gd name="connsiteY2" fmla="*/ 3891280 h 3891280"/>
+                <a:gd name="connsiteX3" fmla="*/ 0 w 3891280"/>
+                <a:gd name="connsiteY3" fmla="*/ 1945640 h 3891280"/>
+                <a:gd name="connsiteX4" fmla="*/ 1945640 w 3891280"/>
+                <a:gd name="connsiteY4" fmla="*/ 0 h 3891280"/>
+              </a:gdLst>
+              <a:ahLst/>
+              <a:cxnLst>
+                <a:cxn ang="0">
+                  <a:pos x="connsiteX0" y="connsiteY0"/>
+                </a:cxn>
+                <a:cxn ang="0">
+                  <a:pos x="connsiteX1" y="connsiteY1"/>
+                </a:cxn>
+                <a:cxn ang="0">
+                  <a:pos x="connsiteX2" y="connsiteY2"/>
+                </a:cxn>
+                <a:cxn ang="0">
+                  <a:pos x="connsiteX3" y="connsiteY3"/>
+                </a:cxn>
+                <a:cxn ang="0">
+                  <a:pos x="connsiteX4" y="connsiteY4"/>
+                </a:cxn>
+              </a:cxnLst>
+              <a:rect l="l" t="t" r="r" b="b"/>
+              <a:pathLst>
+                <a:path w="3891280" h="3891280">
+                  <a:moveTo>
+                    <a:pt x="1945640" y="0"/>
+                  </a:moveTo>
+                  <a:cubicBezTo>
+                    <a:pt x="3020187" y="0"/>
+                    <a:pt x="3891280" y="871093"/>
+                    <a:pt x="3891280" y="1945640"/>
+                  </a:cubicBezTo>
+                  <a:cubicBezTo>
+                    <a:pt x="3891280" y="3020187"/>
+                    <a:pt x="3020187" y="3891280"/>
+                    <a:pt x="1945640" y="3891280"/>
+                  </a:cubicBezTo>
+                  <a:cubicBezTo>
+                    <a:pt x="871093" y="3891280"/>
+                    <a:pt x="0" y="3020187"/>
+                    <a:pt x="0" y="1945640"/>
+                  </a:cubicBezTo>
+                  <a:cubicBezTo>
+                    <a:pt x="0" y="871093"/>
+                    <a:pt x="871093" y="0"/>
+                    <a:pt x="1945640" y="0"/>
+                  </a:cubicBezTo>
+                  <a:close/>
+                </a:path>
+              </a:pathLst>
+            </a:custGeom>
+          </p:spPr>
+        </p:pic>
+        <p:pic>
+          <p:nvPicPr>
+            <p:cNvPr id="5" name="Picture 4">
+              <a:extLst>
+                <a:ext uri="{FF2B5EF4-FFF2-40B4-BE49-F238E27FC236}">
+                  <a16:creationId xmlns:a16="http://schemas.microsoft.com/office/drawing/2014/main" id="{C42F9831-FC97-5C85-8577-6590048978F4}"/>
+                </a:ext>
+              </a:extLst>
+            </p:cNvPr>
+            <p:cNvPicPr>
+              <a:picLocks noChangeAspect="1"/>
+            </p:cNvPicPr>
+            <p:nvPr/>
+          </p:nvPicPr>
+          <p:blipFill>
+            <a:blip r:embed="rId2">
+              <a:alphaModFix/>
+              <a:extLst>
+                <a:ext uri="{28A0092B-C50C-407E-A947-70E740481C1C}">
+                  <a14:useLocalDpi xmlns:a14="http://schemas.microsoft.com/office/drawing/2010/main" val="0"/>
+                </a:ext>
+              </a:extLst>
+            </a:blip>
+            <a:srcRect l="14850" r="22650"/>
+            <a:stretch/>
+          </p:blipFill>
+          <p:spPr>
+            <a:xfrm>
+              <a:off x="861060" y="1574800"/>
+              <a:ext cx="3708400" cy="3708400"/>
+            </a:xfrm>
+            <a:custGeom>
+              <a:avLst/>
+              <a:gdLst>
+                <a:gd name="connsiteX0" fmla="*/ 1945640 w 3891280"/>
+                <a:gd name="connsiteY0" fmla="*/ 0 h 3891280"/>
+                <a:gd name="connsiteX1" fmla="*/ 3891280 w 3891280"/>
+                <a:gd name="connsiteY1" fmla="*/ 1945640 h 3891280"/>
+                <a:gd name="connsiteX2" fmla="*/ 1945640 w 3891280"/>
+                <a:gd name="connsiteY2" fmla="*/ 3891280 h 3891280"/>
+                <a:gd name="connsiteX3" fmla="*/ 0 w 3891280"/>
+                <a:gd name="connsiteY3" fmla="*/ 1945640 h 3891280"/>
+                <a:gd name="connsiteX4" fmla="*/ 1945640 w 3891280"/>
+                <a:gd name="connsiteY4" fmla="*/ 0 h 3891280"/>
+              </a:gdLst>
+              <a:ahLst/>
+              <a:cxnLst>
+                <a:cxn ang="0">
+                  <a:pos x="connsiteX0" y="connsiteY0"/>
+                </a:cxn>
+                <a:cxn ang="0">
+                  <a:pos x="connsiteX1" y="connsiteY1"/>
+                </a:cxn>
+                <a:cxn ang="0">
+                  <a:pos x="connsiteX2" y="connsiteY2"/>
+                </a:cxn>
+                <a:cxn ang="0">
+                  <a:pos x="connsiteX3" y="connsiteY3"/>
+                </a:cxn>
+                <a:cxn ang="0">
+                  <a:pos x="connsiteX4" y="connsiteY4"/>
+                </a:cxn>
+              </a:cxnLst>
+              <a:rect l="l" t="t" r="r" b="b"/>
+              <a:pathLst>
+                <a:path w="3891280" h="3891280">
+                  <a:moveTo>
+                    <a:pt x="1945640" y="0"/>
+                  </a:moveTo>
+                  <a:cubicBezTo>
+                    <a:pt x="3020187" y="0"/>
+                    <a:pt x="3891280" y="871093"/>
+                    <a:pt x="3891280" y="1945640"/>
+                  </a:cubicBezTo>
+                  <a:cubicBezTo>
+                    <a:pt x="3891280" y="3020187"/>
+                    <a:pt x="3020187" y="3891280"/>
+                    <a:pt x="1945640" y="3891280"/>
+                  </a:cubicBezTo>
+                  <a:cubicBezTo>
+                    <a:pt x="871093" y="3891280"/>
+                    <a:pt x="0" y="3020187"/>
+                    <a:pt x="0" y="1945640"/>
+                  </a:cubicBezTo>
+                  <a:cubicBezTo>
+                    <a:pt x="0" y="871093"/>
+                    <a:pt x="871093" y="0"/>
+                    <a:pt x="1945640" y="0"/>
+                  </a:cubicBezTo>
+                  <a:close/>
+                </a:path>
+              </a:pathLst>
+            </a:custGeom>
+          </p:spPr>
+        </p:pic>
+      </p:grpSp>
+      <p:sp>
+        <p:nvSpPr>
+          <p:cNvPr id="8" name="Rectangle 7">
+            <a:extLst>
+              <a:ext uri="{FF2B5EF4-FFF2-40B4-BE49-F238E27FC236}">
+                <a16:creationId xmlns:a16="http://schemas.microsoft.com/office/drawing/2014/main" id="{CFEE4C96-829E-27AB-D817-7178F2E0ACDB}"/>
+              </a:ext>
+            </a:extLst>
+          </p:cNvPr>
+          <p:cNvSpPr/>
+          <p:nvPr/>
+        </p:nvSpPr>
+        <p:spPr>
+          <a:xfrm>
+            <a:off x="0" y="0"/>
+            <a:ext cx="6583680" cy="3891280"/>
+          </a:xfrm>
+          <a:prstGeom prst="rect">
+            <a:avLst/>
+          </a:prstGeom>
+          <a:solidFill>
+            <a:schemeClr val="bg1">
+              <a:alpha val="17000"/>
+            </a:schemeClr>
+          </a:solidFill>
+          <a:ln>
+            <a:solidFill>
+              <a:schemeClr val="bg1"/>
+            </a:solidFill>
+          </a:ln>
+        </p:spPr>
+        <p:style>
+          <a:lnRef idx="2">
+            <a:schemeClr val="accent1">
+              <a:shade val="50000"/>
+            </a:schemeClr>
+          </a:lnRef>
+          <a:fillRef idx="1">
+            <a:schemeClr val="accent1"/>
+          </a:fillRef>
+          <a:effectRef idx="0">
+            <a:schemeClr val="accent1"/>
+          </a:effectRef>
+          <a:fontRef idx="minor">
+            <a:schemeClr val="lt1"/>
+          </a:fontRef>
+        </p:style>
+        <p:txBody>
+          <a:bodyPr rtlCol="0" anchor="ctr"/>
+          <a:lstStyle/>
+          <a:p>
+            <a:pPr algn="ctr"/>
+            <a:endParaRPr lang="it-IT"/>
+          </a:p>
+        </p:txBody>
+      </p:sp>
+    </p:spTree>
+    <p:extLst>
+      <p:ext uri="{BB962C8B-B14F-4D97-AF65-F5344CB8AC3E}">
+        <p14:creationId xmlns:p14="http://schemas.microsoft.com/office/powerpoint/2010/main" val="4011292387"/>
+      </p:ext>
+    </p:extLst>
+  </p:cSld>
+  <p:clrMapOvr>
+    <a:masterClrMapping/>
+  </p:clrMapOvr>
+</p:sld>
+</file>
+
+<file path=ppt/slides/slide6.xml><?xml version="1.0" encoding="utf-8"?>
+<p:sld xmlns:a="http://schemas.openxmlformats.org/drawingml/2006/main" xmlns:r="http://schemas.openxmlformats.org/officeDocument/2006/relationships" xmlns:p="http://schemas.openxmlformats.org/presentationml/2006/main">
+  <p:cSld>
+    <p:spTree>
+      <p:nvGrpSpPr>
+        <p:cNvPr id="1" name="">
+          <a:extLst>
+            <a:ext uri="{FF2B5EF4-FFF2-40B4-BE49-F238E27FC236}">
+              <a16:creationId xmlns:a16="http://schemas.microsoft.com/office/drawing/2014/main" id="{97038FA1-5272-0431-CB13-911FCD1150C8}"/>
+            </a:ext>
+          </a:extLst>
+        </p:cNvPr>
+        <p:cNvGrpSpPr/>
+        <p:nvPr/>
+      </p:nvGrpSpPr>
+      <p:grpSpPr>
+        <a:xfrm>
+          <a:off x="0" y="0"/>
+          <a:ext cx="0" cy="0"/>
+          <a:chOff x="0" y="0"/>
+          <a:chExt cx="0" cy="0"/>
+        </a:xfrm>
+      </p:grpSpPr>
+      <p:sp>
+        <p:nvSpPr>
+          <p:cNvPr id="7" name="Rectangle 6">
+            <a:extLst>
+              <a:ext uri="{FF2B5EF4-FFF2-40B4-BE49-F238E27FC236}">
+                <a16:creationId xmlns:a16="http://schemas.microsoft.com/office/drawing/2014/main" id="{7D1E5580-B561-57BB-5479-9E3EB91E1C90}"/>
+              </a:ext>
+            </a:extLst>
+          </p:cNvPr>
+          <p:cNvSpPr/>
+          <p:nvPr/>
+        </p:nvSpPr>
+        <p:spPr>
+          <a:xfrm>
+            <a:off x="0" y="0"/>
+            <a:ext cx="6583680" cy="3891280"/>
+          </a:xfrm>
+          <a:prstGeom prst="rect">
+            <a:avLst/>
+          </a:prstGeom>
+          <a:solidFill>
+            <a:schemeClr val="bg1"/>
+          </a:solidFill>
+          <a:ln>
+            <a:solidFill>
+              <a:schemeClr val="bg1"/>
+            </a:solidFill>
+          </a:ln>
+        </p:spPr>
+        <p:style>
+          <a:lnRef idx="2">
+            <a:schemeClr val="accent1">
+              <a:shade val="50000"/>
+            </a:schemeClr>
+          </a:lnRef>
+          <a:fillRef idx="1">
+            <a:schemeClr val="accent1"/>
+          </a:fillRef>
+          <a:effectRef idx="0">
+            <a:schemeClr val="accent1"/>
+          </a:effectRef>
+          <a:fontRef idx="minor">
+            <a:schemeClr val="lt1"/>
+          </a:fontRef>
+        </p:style>
+        <p:txBody>
+          <a:bodyPr rtlCol="0" anchor="ctr"/>
+          <a:lstStyle/>
+          <a:p>
+            <a:pPr algn="ctr"/>
+            <a:endParaRPr lang="it-IT"/>
+          </a:p>
+        </p:txBody>
+      </p:sp>
+      <p:grpSp>
+        <p:nvGrpSpPr>
+          <p:cNvPr id="8" name="Group 7">
+            <a:extLst>
+              <a:ext uri="{FF2B5EF4-FFF2-40B4-BE49-F238E27FC236}">
+                <a16:creationId xmlns:a16="http://schemas.microsoft.com/office/drawing/2014/main" id="{3188279F-69C1-73D9-3D9A-B4F4503179B1}"/>
+              </a:ext>
+            </a:extLst>
+          </p:cNvPr>
+          <p:cNvGrpSpPr/>
+          <p:nvPr/>
+        </p:nvGrpSpPr>
+        <p:grpSpPr>
+          <a:xfrm>
+            <a:off x="497332" y="1076960"/>
+            <a:ext cx="4618736" cy="4618736"/>
+            <a:chOff x="497332" y="1076960"/>
+            <a:chExt cx="4618736" cy="4618736"/>
+          </a:xfrm>
+        </p:grpSpPr>
+        <p:pic>
+          <p:nvPicPr>
+            <p:cNvPr id="6" name="Picture 5">
+              <a:extLst>
+                <a:ext uri="{FF2B5EF4-FFF2-40B4-BE49-F238E27FC236}">
+                  <a16:creationId xmlns:a16="http://schemas.microsoft.com/office/drawing/2014/main" id="{B4E5DC63-4C58-F4C0-FC26-02797FF23A8D}"/>
+                </a:ext>
+              </a:extLst>
+            </p:cNvPr>
+            <p:cNvPicPr>
+              <a:picLocks noChangeAspect="1"/>
+            </p:cNvPicPr>
+            <p:nvPr/>
+          </p:nvPicPr>
+          <p:blipFill>
+            <a:blip r:embed="rId2">
+              <a:extLst>
+                <a:ext uri="{28A0092B-C50C-407E-A947-70E740481C1C}">
+                  <a14:useLocalDpi xmlns:a14="http://schemas.microsoft.com/office/drawing/2010/main" val="0"/>
+                </a:ext>
+              </a:extLst>
+            </a:blip>
+            <a:srcRect l="14850" r="22650"/>
+            <a:stretch/>
+          </p:blipFill>
+          <p:spPr>
+            <a:xfrm>
+              <a:off x="497332" y="1076960"/>
+              <a:ext cx="4618736" cy="4618736"/>
+            </a:xfrm>
+            <a:custGeom>
+              <a:avLst/>
+              <a:gdLst>
+                <a:gd name="connsiteX0" fmla="*/ 1945640 w 3891280"/>
+                <a:gd name="connsiteY0" fmla="*/ 0 h 3891280"/>
+                <a:gd name="connsiteX1" fmla="*/ 3891280 w 3891280"/>
+                <a:gd name="connsiteY1" fmla="*/ 1945640 h 3891280"/>
+                <a:gd name="connsiteX2" fmla="*/ 1945640 w 3891280"/>
+                <a:gd name="connsiteY2" fmla="*/ 3891280 h 3891280"/>
+                <a:gd name="connsiteX3" fmla="*/ 0 w 3891280"/>
+                <a:gd name="connsiteY3" fmla="*/ 1945640 h 3891280"/>
+                <a:gd name="connsiteX4" fmla="*/ 1945640 w 3891280"/>
+                <a:gd name="connsiteY4" fmla="*/ 0 h 3891280"/>
+              </a:gdLst>
+              <a:ahLst/>
+              <a:cxnLst>
+                <a:cxn ang="0">
+                  <a:pos x="connsiteX0" y="connsiteY0"/>
+                </a:cxn>
+                <a:cxn ang="0">
+                  <a:pos x="connsiteX1" y="connsiteY1"/>
+                </a:cxn>
+                <a:cxn ang="0">
+                  <a:pos x="connsiteX2" y="connsiteY2"/>
+                </a:cxn>
+                <a:cxn ang="0">
+                  <a:pos x="connsiteX3" y="connsiteY3"/>
+                </a:cxn>
+                <a:cxn ang="0">
+                  <a:pos x="connsiteX4" y="connsiteY4"/>
+                </a:cxn>
+              </a:cxnLst>
+              <a:rect l="l" t="t" r="r" b="b"/>
+              <a:pathLst>
+                <a:path w="3891280" h="3891280">
+                  <a:moveTo>
+                    <a:pt x="1945640" y="0"/>
+                  </a:moveTo>
+                  <a:cubicBezTo>
+                    <a:pt x="3020187" y="0"/>
+                    <a:pt x="3891280" y="871093"/>
+                    <a:pt x="3891280" y="1945640"/>
+                  </a:cubicBezTo>
+                  <a:cubicBezTo>
+                    <a:pt x="3891280" y="3020187"/>
+                    <a:pt x="3020187" y="3891280"/>
+                    <a:pt x="1945640" y="3891280"/>
+                  </a:cubicBezTo>
+                  <a:cubicBezTo>
+                    <a:pt x="871093" y="3891280"/>
+                    <a:pt x="0" y="3020187"/>
+                    <a:pt x="0" y="1945640"/>
+                  </a:cubicBezTo>
+                  <a:cubicBezTo>
+                    <a:pt x="0" y="871093"/>
+                    <a:pt x="871093" y="0"/>
+                    <a:pt x="1945640" y="0"/>
+                  </a:cubicBezTo>
+                  <a:close/>
+                </a:path>
+              </a:pathLst>
+            </a:custGeom>
+          </p:spPr>
+        </p:pic>
+        <p:pic>
+          <p:nvPicPr>
+            <p:cNvPr id="5" name="Picture 4">
+              <a:extLst>
+                <a:ext uri="{FF2B5EF4-FFF2-40B4-BE49-F238E27FC236}">
+                  <a16:creationId xmlns:a16="http://schemas.microsoft.com/office/drawing/2014/main" id="{01330D20-84CA-EB01-C1B5-0C16711542AF}"/>
+                </a:ext>
+              </a:extLst>
+            </p:cNvPr>
+            <p:cNvPicPr>
+              <a:picLocks noChangeAspect="1"/>
+            </p:cNvPicPr>
+            <p:nvPr/>
+          </p:nvPicPr>
+          <p:blipFill>
+            <a:blip r:embed="rId2">
+              <a:extLst>
+                <a:ext uri="{28A0092B-C50C-407E-A947-70E740481C1C}">
+                  <a14:useLocalDpi xmlns:a14="http://schemas.microsoft.com/office/drawing/2010/main" val="0"/>
+                </a:ext>
+              </a:extLst>
+            </a:blip>
+            <a:srcRect l="14850" r="22650"/>
+            <a:stretch/>
+          </p:blipFill>
+          <p:spPr>
+            <a:xfrm>
+              <a:off x="861060" y="1574800"/>
+              <a:ext cx="3708400" cy="3708400"/>
+            </a:xfrm>
+            <a:custGeom>
+              <a:avLst/>
+              <a:gdLst>
+                <a:gd name="connsiteX0" fmla="*/ 1945640 w 3891280"/>
+                <a:gd name="connsiteY0" fmla="*/ 0 h 3891280"/>
+                <a:gd name="connsiteX1" fmla="*/ 3891280 w 3891280"/>
+                <a:gd name="connsiteY1" fmla="*/ 1945640 h 3891280"/>
+                <a:gd name="connsiteX2" fmla="*/ 1945640 w 3891280"/>
+                <a:gd name="connsiteY2" fmla="*/ 3891280 h 3891280"/>
+                <a:gd name="connsiteX3" fmla="*/ 0 w 3891280"/>
+                <a:gd name="connsiteY3" fmla="*/ 1945640 h 3891280"/>
+                <a:gd name="connsiteX4" fmla="*/ 1945640 w 3891280"/>
+                <a:gd name="connsiteY4" fmla="*/ 0 h 3891280"/>
+              </a:gdLst>
+              <a:ahLst/>
+              <a:cxnLst>
+                <a:cxn ang="0">
+                  <a:pos x="connsiteX0" y="connsiteY0"/>
+                </a:cxn>
+                <a:cxn ang="0">
+                  <a:pos x="connsiteX1" y="connsiteY1"/>
+                </a:cxn>
+                <a:cxn ang="0">
+                  <a:pos x="connsiteX2" y="connsiteY2"/>
+                </a:cxn>
+                <a:cxn ang="0">
+                  <a:pos x="connsiteX3" y="connsiteY3"/>
+                </a:cxn>
+                <a:cxn ang="0">
+                  <a:pos x="connsiteX4" y="connsiteY4"/>
+                </a:cxn>
+              </a:cxnLst>
+              <a:rect l="l" t="t" r="r" b="b"/>
+              <a:pathLst>
+                <a:path w="3891280" h="3891280">
+                  <a:moveTo>
+                    <a:pt x="1945640" y="0"/>
+                  </a:moveTo>
+                  <a:cubicBezTo>
+                    <a:pt x="3020187" y="0"/>
+                    <a:pt x="3891280" y="871093"/>
+                    <a:pt x="3891280" y="1945640"/>
+                  </a:cubicBezTo>
+                  <a:cubicBezTo>
+                    <a:pt x="3891280" y="3020187"/>
+                    <a:pt x="3020187" y="3891280"/>
+                    <a:pt x="1945640" y="3891280"/>
+                  </a:cubicBezTo>
+                  <a:cubicBezTo>
+                    <a:pt x="871093" y="3891280"/>
+                    <a:pt x="0" y="3020187"/>
+                    <a:pt x="0" y="1945640"/>
+                  </a:cubicBezTo>
+                  <a:cubicBezTo>
+                    <a:pt x="0" y="871093"/>
+                    <a:pt x="871093" y="0"/>
+                    <a:pt x="1945640" y="0"/>
+                  </a:cubicBezTo>
+                  <a:close/>
+                </a:path>
+              </a:pathLst>
+            </a:custGeom>
+          </p:spPr>
+        </p:pic>
+      </p:grpSp>
+      <p:pic>
+        <p:nvPicPr>
+          <p:cNvPr id="2" name="Picture 1">
+            <a:extLst>
+              <a:ext uri="{FF2B5EF4-FFF2-40B4-BE49-F238E27FC236}">
+                <a16:creationId xmlns:a16="http://schemas.microsoft.com/office/drawing/2014/main" id="{990572E3-7EBB-764B-29A6-391900F9B3CB}"/>
+              </a:ext>
+            </a:extLst>
+          </p:cNvPr>
+          <p:cNvPicPr>
+            <a:picLocks noChangeAspect="1"/>
+          </p:cNvPicPr>
+          <p:nvPr/>
+        </p:nvPicPr>
+        <p:blipFill>
+          <a:blip r:embed="rId3">
+            <a:alphaModFix amt="85000"/>
+            <a:extLst>
+              <a:ext uri="{28A0092B-C50C-407E-A947-70E740481C1C}">
+                <a14:useLocalDpi xmlns:a14="http://schemas.microsoft.com/office/drawing/2010/main" val="0"/>
+              </a:ext>
+            </a:extLst>
+          </a:blip>
+          <a:stretch>
+            <a:fillRect/>
+          </a:stretch>
+        </p:blipFill>
+        <p:spPr>
+          <a:xfrm>
+            <a:off x="5613400" y="304800"/>
+            <a:ext cx="3891280" cy="3891280"/>
+          </a:xfrm>
+          <a:prstGeom prst="rect">
+            <a:avLst/>
+          </a:prstGeom>
+        </p:spPr>
+      </p:pic>
+    </p:spTree>
+    <p:extLst>
+      <p:ext uri="{BB962C8B-B14F-4D97-AF65-F5344CB8AC3E}">
+        <p14:creationId xmlns:p14="http://schemas.microsoft.com/office/powerpoint/2010/main" val="4165855930"/>
+      </p:ext>
+    </p:extLst>
+  </p:cSld>
+  <p:clrMapOvr>
+    <a:masterClrMapping/>
+  </p:clrMapOvr>
+</p:sld>
+</file>
+
 <file path=ppt/theme/theme1.xml><?xml version="1.0" encoding="utf-8"?>
 <a:theme xmlns:a="http://schemas.openxmlformats.org/drawingml/2006/main" name="Office Theme">
   <a:themeElements>

</xml_diff>